<commit_message>
Framework-first revision: placeholder KPI numbers, private delivery scoreboard, punctuation scrub
All number KPIs become placeholders pending bottom-up agreement with Ivan.
Delivery Scoreboard moves out of the shared tracker into its own file
(tracker stays team-visible, scores stay private). Em dashes and middot
separators removed from all copy.

Co-Authored-By: Claude Fable 5 <noreply@anthropic.com>
Claude-Session: https://claude.ai/code/session_01RGX7fKtxmHSTi6NvK3idJW
</commit_message>
<xml_diff>
--- a/team-performance/POS_Product_H2_2026_KPI_OnePager.pptx
+++ b/team-performance/POS_Product_H2_2026_KPI_OnePager.pptx
@@ -908,7 +908,7 @@
                 <a:ea typeface="Arial" pitchFamily="34" charset="-122"/>
                 <a:cs typeface="Arial" pitchFamily="34" charset="-120"/>
               </a:rPr>
-              <a:t>POS Product Team — H2 2026 KPIs</a:t>
+              <a:t>POS Product Team KPIs, H2 2026</a:t>
             </a:r>
             <a:endParaRPr lang="en-US" sz="2300" dirty="0"/>
           </a:p>
@@ -947,7 +947,7 @@
                 <a:ea typeface="Arial" pitchFamily="34" charset="-122"/>
                 <a:cs typeface="Arial" pitchFamily="34" charset="-120"/>
               </a:rPr>
-              <a:t>Kurt Molina  ·  alignment w/ Ivan  ·  Jul 2026</a:t>
+              <a:t>Kurt Molina, for alignment with Ivan, Jul 2026</a:t>
             </a:r>
             <a:endParaRPr lang="en-US" sz="900" dirty="0"/>
           </a:p>
@@ -978,7 +978,7 @@
               <a:buNone/>
             </a:pPr>
             <a:r>
-              <a:rPr lang="en-US" sz="1000" dirty="0">
+              <a:rPr lang="en-US" sz="950" dirty="0">
                 <a:solidFill>
                   <a:srgbClr val="1A1A1A"/>
                 </a:solidFill>
@@ -986,9 +986,9 @@
                 <a:ea typeface="Arial" pitchFamily="34" charset="-122"/>
                 <a:cs typeface="Arial" pitchFamily="34" charset="-120"/>
               </a:rPr>
-              <a:t>North star: absolute PBT per line. Three tiers, phase-aware, delivery managed on business impact — per our 29 Jun call and the QuantumLight (Revolut) performance playbook.</a:t>
-            </a:r>
-            <a:endParaRPr lang="en-US" sz="1000" dirty="0"/>
+              <a:t>Proposed framework for discussion and approval. North star: absolute PBT per line, three tiers, phase aware, delivery managed on business impact. Combines our 29 Jun call with the QuantumLight (Revolut) playbook. All number KPIs are placeholders until set bottom-up.</a:t>
+            </a:r>
+            <a:endParaRPr lang="en-US" sz="950" dirty="0"/>
           </a:p>
         </p:txBody>
       </p:sp>
@@ -1025,7 +1025,7 @@
                 <a:ea typeface="Arial" pitchFamily="34" charset="-122"/>
                 <a:cs typeface="Arial" pitchFamily="34" charset="-120"/>
               </a:rPr>
-              <a:t>1 · THE METRIC TREE</a:t>
+              <a:t>1. THE METRIC TREE</a:t>
             </a:r>
             <a:endParaRPr lang="en-US" sz="1050" dirty="0"/>
           </a:p>
@@ -1068,7 +1068,7 @@
                 <a:ea typeface="Arial" pitchFamily="34" charset="-122"/>
                 <a:cs typeface="Arial" pitchFamily="34" charset="-120"/>
               </a:rPr>
-              <a:t>TIER 0 · NORTH STAR — absolute PBT (P) per line</a:t>
+              <a:t>TIER 0 NORTH STAR: absolute PBT (pesos) per line</a:t>
             </a:r>
             <a:endParaRPr lang="en-US" sz="950" dirty="0"/>
           </a:p>
@@ -1085,7 +1085,7 @@
                 <a:ea typeface="Arial" pitchFamily="34" charset="-122"/>
                 <a:cs typeface="Arial" pitchFamily="34" charset="-120"/>
               </a:rPr>
-              <a:t>QRPh  ·  Online  ·  Moto / Deals  ·  Credit Line  ·  Solar  ·  Offline</a:t>
+              <a:t>QRPh, Online, Moto/Deals, Credit Line, Solar, Offline</a:t>
             </a:r>
             <a:endParaRPr lang="en-US" sz="950" dirty="0"/>
           </a:p>
@@ -1124,7 +1124,7 @@
                 <a:ea typeface="Arial" pitchFamily="34" charset="-122"/>
                 <a:cs typeface="Arial" pitchFamily="34" charset="-120"/>
               </a:rPr>
-              <a:t>PBT  =  Volume (disbursements)  ×  Profitability %</a:t>
+              <a:t>PBT  =  Volume (disbursements)  x  Profitability %</a:t>
             </a:r>
             <a:endParaRPr lang="en-US" sz="950" dirty="0"/>
           </a:p>
@@ -1167,7 +1167,7 @@
                 <a:ea typeface="Arial" pitchFamily="34" charset="-122"/>
                 <a:cs typeface="Arial" pitchFamily="34" charset="-120"/>
               </a:rPr>
-              <a:t>TIER 1 · VOLUME</a:t>
+              <a:t>TIER 1: VOLUME</a:t>
             </a:r>
             <a:endParaRPr lang="en-US" sz="850" dirty="0"/>
           </a:p>
@@ -1184,7 +1184,7 @@
                 <a:ea typeface="Arial" pitchFamily="34" charset="-122"/>
                 <a:cs typeface="Arial" pitchFamily="34" charset="-120"/>
               </a:rPr>
-              <a:t>portfolio size / share</a:t>
+              <a:t>portfolio size and share</a:t>
             </a:r>
             <a:endParaRPr lang="en-US" sz="850" dirty="0"/>
           </a:p>
@@ -1227,7 +1227,7 @@
                 <a:ea typeface="Arial" pitchFamily="34" charset="-122"/>
                 <a:cs typeface="Arial" pitchFamily="34" charset="-120"/>
               </a:rPr>
-              <a:t>TIER 1 · PROFITABILITY</a:t>
+              <a:t>TIER 1: PROFITABILITY</a:t>
             </a:r>
             <a:endParaRPr lang="en-US" sz="850" dirty="0"/>
           </a:p>
@@ -1466,7 +1466,7 @@
                 <a:ea typeface="Arial" pitchFamily="34" charset="-122"/>
                 <a:cs typeface="Arial" pitchFamily="34" charset="-120"/>
               </a:rPr>
-              <a:t>TIER 3 — what the team moves daily</a:t>
+              <a:t>TIER 3: what the team moves daily</a:t>
             </a:r>
             <a:endParaRPr lang="en-US" sz="850" dirty="0"/>
           </a:p>
@@ -1486,7 +1486,7 @@
                 <a:ea typeface="Arial" pitchFamily="34" charset="-122"/>
                 <a:cs typeface="Arial" pitchFamily="34" charset="-120"/>
               </a:rPr>
-              <a:t>Margin:  markup rate · take-up rate · MDR</a:t>
+              <a:t>Margin: markup rate, take-up rate, MDR</a:t>
             </a:r>
             <a:endParaRPr lang="en-US" sz="850" dirty="0"/>
           </a:p>
@@ -1506,7 +1506,7 @@
                 <a:ea typeface="Arial" pitchFamily="34" charset="-122"/>
                 <a:cs typeface="Arial" pitchFamily="34" charset="-120"/>
               </a:rPr>
-              <a:t>Risk:  cost of risk · NPM per merchant</a:t>
+              <a:t>Risk: cost of risk, NPM per merchant</a:t>
             </a:r>
             <a:endParaRPr lang="en-US" sz="850" dirty="0"/>
           </a:p>
@@ -1526,7 +1526,7 @@
                 <a:ea typeface="Arial" pitchFamily="34" charset="-122"/>
                 <a:cs typeface="Arial" pitchFamily="34" charset="-120"/>
               </a:rPr>
-              <a:t>Opex:  opex per disbursement · sales-agent economics</a:t>
+              <a:t>Opex: opex per disbursement, sales-agent economics</a:t>
             </a:r>
             <a:endParaRPr lang="en-US" sz="850" dirty="0"/>
           </a:p>
@@ -1546,7 +1546,7 @@
                 <a:ea typeface="Arial" pitchFamily="34" charset="-122"/>
                 <a:cs typeface="Arial" pitchFamily="34" charset="-120"/>
               </a:rPr>
-              <a:t>Volume:  disb run rate · acceptance &amp; conversion · active partners · CL utilization</a:t>
+              <a:t>Volume: disb run rate, acceptance and conversion, active partners, CL utilization</a:t>
             </a:r>
             <a:endParaRPr lang="en-US" sz="850" dirty="0"/>
           </a:p>
@@ -1603,7 +1603,7 @@
                 <a:ea typeface="Arial" pitchFamily="34" charset="-122"/>
                 <a:cs typeface="Arial" pitchFamily="34" charset="-120"/>
               </a:rPr>
-              <a:t>Star &amp; Question marks → push volume (all PMs sit here). Cash cow (Offline) → maintain, no PM. Low profitability is acceptable today where the phase says grow the size.</a:t>
+              <a:t>Star and Question marks push volume (all PMs sit here). Cash cow (Offline) is maintain only, no PM. Low profitability is acceptable today where the phase says grow the size.</a:t>
             </a:r>
             <a:endParaRPr lang="en-US" sz="850" dirty="0"/>
           </a:p>
@@ -1642,7 +1642,7 @@
                 <a:ea typeface="Arial" pitchFamily="34" charset="-122"/>
                 <a:cs typeface="Arial" pitchFamily="34" charset="-120"/>
               </a:rPr>
-              <a:t>BASELINE — MAY 2026 READ</a:t>
+              <a:t>NUMBERS POLICY</a:t>
             </a:r>
             <a:endParaRPr lang="en-US" sz="850" dirty="0"/>
           </a:p>
@@ -1657,7 +1657,7 @@
         <p:spPr>
           <a:xfrm>
             <a:off x="411480" y="5138928"/>
-            <a:ext cx="3675888" cy="868680"/>
+            <a:ext cx="3675888" cy="640080"/>
           </a:xfrm>
           <a:prstGeom prst="rect">
             <a:avLst/>
@@ -1684,7 +1684,7 @@
                 <a:ea typeface="Arial" pitchFamily="34" charset="-122"/>
                 <a:cs typeface="Arial" pitchFamily="34" charset="-120"/>
               </a:rPr>
-              <a:t>Overall PBT slightly negative. QRPh small positive · Online possibly positive, small · Moto calculated negative, long run unknown · Credit Line launched 15 Jul · Solar kill-or-keep pending. The H2 job: grow the stars and question marks into the absolute number.</a:t>
+              <a:t>Every number KPI is a placeholder (P__) until we set it bottom-up and approve it together. First pass on this call, then a standing review at the monthly KPI readout.</a:t>
             </a:r>
             <a:endParaRPr lang="en-US" sz="850" dirty="0"/>
           </a:p>
@@ -1723,7 +1723,7 @@
                 <a:ea typeface="Arial" pitchFamily="34" charset="-122"/>
                 <a:cs typeface="Arial" pitchFamily="34" charset="-120"/>
               </a:rPr>
-              <a:t>2 · OWNER KPIs — THREE EACH</a:t>
+              <a:t>2. OWNER KPIs, THREE EACH</a:t>
             </a:r>
             <a:endParaRPr lang="en-US" sz="1050" dirty="0"/>
           </a:p>
@@ -1762,7 +1762,7 @@
                 <a:ea typeface="Arial" pitchFamily="34" charset="-122"/>
                 <a:cs typeface="Arial" pitchFamily="34" charset="-120"/>
               </a:rPr>
-              <a:t>D1 line outcome · D2 key driver · D3 delivery (all owners)</a:t>
+              <a:t>D1 line outcome, D2 key driver, D3 delivery (all owners)</a:t>
             </a:r>
             <a:endParaRPr lang="en-US" sz="850" dirty="0"/>
           </a:p>
@@ -1806,7 +1806,7 @@
                 <a:ea typeface="Arial" pitchFamily="34" charset="-122"/>
                 <a:cs typeface="Arial" pitchFamily="34" charset="-120"/>
               </a:rPr>
-              <a:t>JV Manlangit — Moto &amp; SAP</a:t>
+              <a:t>JV Manlangit, Moto and SAP</a:t>
             </a:r>
             <a:endParaRPr lang="en-US" sz="850" dirty="0"/>
           </a:p>
@@ -1826,7 +1826,7 @@
                 <a:ea typeface="Arial" pitchFamily="34" charset="-122"/>
                 <a:cs typeface="Arial" pitchFamily="34" charset="-120"/>
               </a:rPr>
-              <a:t>Moto P15M/mo (Nhat-gated)  ·  disb per active agent P315K → 500K+</a:t>
+              <a:t>Moto monthly disbursement P__M (Nhat-gated), disbursement per active sales agent P__</a:t>
             </a:r>
             <a:endParaRPr lang="en-US" sz="850" dirty="0"/>
           </a:p>
@@ -1868,7 +1868,7 @@
                 <a:ea typeface="Arial" pitchFamily="34" charset="-122"/>
                 <a:cs typeface="Arial" pitchFamily="34" charset="-120"/>
               </a:rPr>
-              <a:t>Anton Betia — Deals &amp; Solar</a:t>
+              <a:t>Anton Betia, Deals and Solar</a:t>
             </a:r>
             <a:endParaRPr lang="en-US" sz="850" dirty="0"/>
           </a:p>
@@ -1888,7 +1888,7 @@
                 <a:ea typeface="Arial" pitchFamily="34" charset="-122"/>
                 <a:cs typeface="Arial" pitchFamily="34" charset="-120"/>
               </a:rPr>
-              <a:t>Deals P25 → 50 → 100M/mo staged, at positive NPM  ·  acceptance &amp; conversion (salvage plan on rejects)</a:t>
+              <a:t>Deals monthly disbursement P__M staged at positive NPM, acceptance and conversion (salvage plan on rejects)</a:t>
             </a:r>
             <a:endParaRPr lang="en-US" sz="850" dirty="0"/>
           </a:p>
@@ -1932,7 +1932,7 @@
                 <a:ea typeface="Arial" pitchFamily="34" charset="-122"/>
                 <a:cs typeface="Arial" pitchFamily="34" charset="-120"/>
               </a:rPr>
-              <a:t>Manzil Balani — Deals BD</a:t>
+              <a:t>Manzil Balani, Deals BD</a:t>
             </a:r>
             <a:endParaRPr lang="en-US" sz="850" dirty="0"/>
           </a:p>
@@ -1952,7 +1952,7 @@
                 <a:ea typeface="Arial" pitchFamily="34" charset="-122"/>
                 <a:cs typeface="Arial" pitchFamily="34" charset="-120"/>
               </a:rPr>
-              <a:t>Managed-account disb (ProTech · Maxicare · 3Cat)  ·  new merchants live, ticket uplift P1,000–2,000</a:t>
+              <a:t>Managed-account disbursement (ProTech, Maxicare, 3Cat), new merchants live, ticket uplift P__</a:t>
             </a:r>
             <a:endParaRPr lang="en-US" sz="850" dirty="0"/>
           </a:p>
@@ -1994,7 +1994,7 @@
                 <a:ea typeface="Arial" pitchFamily="34" charset="-122"/>
                 <a:cs typeface="Arial" pitchFamily="34" charset="-120"/>
               </a:rPr>
-              <a:t>Elias Marcella — Credit Line &amp; Card</a:t>
+              <a:t>Elias Marcella, Credit Line and Card</a:t>
             </a:r>
             <a:endParaRPr lang="en-US" sz="850" dirty="0"/>
           </a:p>
@@ -2014,7 +2014,7 @@
                 <a:ea typeface="Arial" pitchFamily="34" charset="-122"/>
                 <a:cs typeface="Arial" pitchFamily="34" charset="-120"/>
               </a:rPr>
-              <a:t>CL utilization &amp; drawdown (target set ~15 Aug)  ·  per-card break-even at CAC P300–500</a:t>
+              <a:t>CL utilization and drawdown (target set ~30d post-launch), per-card break-even at CAC P__</a:t>
             </a:r>
             <a:endParaRPr lang="en-US" sz="850" dirty="0"/>
           </a:p>
@@ -2058,7 +2058,7 @@
                 <a:ea typeface="Arial" pitchFamily="34" charset="-122"/>
                 <a:cs typeface="Arial" pitchFamily="34" charset="-120"/>
               </a:rPr>
-              <a:t>Jastin Lagumbay — QRPh &amp; Onboarding</a:t>
+              <a:t>Jastin Lagumbay, QRPh and Onboarding</a:t>
             </a:r>
             <a:endParaRPr lang="en-US" sz="850" dirty="0"/>
           </a:p>
@@ -2078,7 +2078,7 @@
                 <a:ea typeface="Arial" pitchFamily="34" charset="-122"/>
                 <a:cs typeface="Arial" pitchFamily="34" charset="-120"/>
               </a:rPr>
-              <a:t>QRPh P107M/mo run rate  ·  onboarding cycle time signed → live, zero config errors</a:t>
+              <a:t>QRPh monthly run rate P__M, onboarding cycle time from signed to live, zero config errors</a:t>
             </a:r>
             <a:endParaRPr lang="en-US" sz="850" dirty="0"/>
           </a:p>
@@ -2137,7 +2137,7 @@
                 <a:ea typeface="Arial" pitchFamily="34" charset="-122"/>
                 <a:cs typeface="Arial" pitchFamily="34" charset="-120"/>
               </a:rPr>
-              <a:t>agreed roadmap steps delivered on pace — scored weekly in the tracker.   </a:t>
+              <a:t>agreed roadmap steps delivered on pace, scored weekly.   </a:t>
             </a:r>
             <a:pPr indent="0" marL="0">
               <a:lnSpc>
@@ -2171,7 +2171,7 @@
                 <a:ea typeface="Arial" pitchFamily="34" charset="-122"/>
                 <a:cs typeface="Arial" pitchFamily="34" charset="-120"/>
               </a:rPr>
-              <a:t>Nhat (PBT-per-line model) · Jenny (metric-tree dashboard) · Billy (release quality gate).</a:t>
+              <a:t>Nhat (PBT per line model), Jenny (metric tree dashboard), Billy (release quality gate).</a:t>
             </a:r>
             <a:endParaRPr lang="en-US" sz="850" dirty="0"/>
           </a:p>
@@ -2210,7 +2210,7 @@
                 <a:ea typeface="Arial" pitchFamily="34" charset="-122"/>
                 <a:cs typeface="Arial" pitchFamily="34" charset="-120"/>
               </a:rPr>
-              <a:t>3 · TARGETS ARE SET BOTTOM-UP</a:t>
+              <a:t>3. TARGETS ARE SET BOTTOM-UP</a:t>
             </a:r>
             <a:endParaRPr lang="en-US" sz="1050" dirty="0"/>
           </a:p>
@@ -2255,7 +2255,7 @@
                 <a:ea typeface="Arial" pitchFamily="34" charset="-122"/>
                 <a:cs typeface="Arial" pitchFamily="34" charset="-120"/>
               </a:rPr>
-              <a:t>Where we are → why (margin, risk or opex?) → agreed actions → estimated impact → deadline  ⇒  the target.</a:t>
+              <a:t>Where we are → why (margin, risk or opex?) → agreed actions → estimated impact → deadline → the target.</a:t>
             </a:r>
             <a:endParaRPr lang="en-US" sz="880" dirty="0"/>
           </a:p>
@@ -2278,7 +2278,7 @@
                 <a:ea typeface="Arial" pitchFamily="34" charset="-122"/>
                 <a:cs typeface="Arial" pitchFamily="34" charset="-120"/>
               </a:rPr>
-              <a:t>e.g. salvage ~20% of Deals rejects: at ~5% conversion that can triple volume — that estimate, on a date, becomes the month's number.</a:t>
+              <a:t>e.g. a reject-salvage plan on Deals: estimate how much can be converted, put a date on it, and that estimate becomes the month's target.</a:t>
             </a:r>
             <a:endParaRPr lang="en-US" sz="880" dirty="0"/>
           </a:p>
@@ -2340,7 +2340,7 @@
                 <a:ea typeface="Arial" pitchFamily="34" charset="-122"/>
                 <a:cs typeface="Arial" pitchFamily="34" charset="-120"/>
               </a:rPr>
-              <a:t>4 · TRACKING RHYTHM — STRICT FROM JUL</a:t>
+              <a:t>4. TRACKING RHYTHM, STRICT FROM JULY</a:t>
             </a:r>
             <a:endParaRPr lang="en-US" sz="1050" dirty="0"/>
           </a:p>
@@ -2355,7 +2355,7 @@
         <p:spPr>
           <a:xfrm>
             <a:off x="8613648" y="1243584"/>
-            <a:ext cx="3163824" cy="475488"/>
+            <a:ext cx="3163824" cy="758952"/>
           </a:xfrm>
           <a:prstGeom prst="rect">
             <a:avLst/>
@@ -2382,7 +2382,7 @@
                 <a:ea typeface="Arial" pitchFamily="34" charset="-122"/>
                 <a:cs typeface="Arial" pitchFamily="34" charset="-120"/>
               </a:rPr>
-              <a:t>Weekly · Mon standup</a:t>
+              <a:t>Weekly: Monday standup</a:t>
             </a:r>
             <a:endParaRPr lang="en-US" sz="850" dirty="0"/>
           </a:p>
@@ -2402,7 +2402,7 @@
                 <a:ea typeface="Arial" pitchFamily="34" charset="-122"/>
                 <a:cs typeface="Arial" pitchFamily="34" charset="-120"/>
               </a:rPr>
-              <a:t>Exec tracker: status, due vs delivered, blockers, impact. Detail stays in ClickUp (linked per row).</a:t>
+              <a:t>Exec tracker, shared with the whole team: status, due vs delivered, blockers, impact. Detail stays in ClickUp (linked per row). Delivery scores are kept separately by Kurt.</a:t>
             </a:r>
             <a:endParaRPr lang="en-US" sz="850" dirty="0"/>
           </a:p>
@@ -2416,7 +2416,7 @@
         </p:nvSpPr>
         <p:spPr>
           <a:xfrm>
-            <a:off x="8613648" y="1824228"/>
+            <a:off x="8613648" y="2107692"/>
             <a:ext cx="3163824" cy="475488"/>
           </a:xfrm>
           <a:prstGeom prst="rect">
@@ -2444,7 +2444,7 @@
                 <a:ea typeface="Arial" pitchFamily="34" charset="-122"/>
                 <a:cs typeface="Arial" pitchFamily="34" charset="-120"/>
               </a:rPr>
-              <a:t>Monthly · KPI readout</a:t>
+              <a:t>Monthly: KPI readout</a:t>
             </a:r>
             <a:endParaRPr lang="en-US" sz="850" dirty="0"/>
           </a:p>
@@ -2464,7 +2464,7 @@
                 <a:ea typeface="Arial" pitchFamily="34" charset="-122"/>
                 <a:cs typeface="Arial" pitchFamily="34" charset="-120"/>
               </a:rPr>
-              <a:t>Target vs actual per line — Nhat's PBT model + Jenny's dashboard.</a:t>
+              <a:t>Target vs actual per line, from Nhat's PBT model and Jenny's dashboard.</a:t>
             </a:r>
             <a:endParaRPr lang="en-US" sz="850" dirty="0"/>
           </a:p>
@@ -2478,7 +2478,7 @@
         </p:nvSpPr>
         <p:spPr>
           <a:xfrm>
-            <a:off x="8613648" y="2404872"/>
+            <a:off x="8613648" y="2688336"/>
             <a:ext cx="3163824" cy="758952"/>
           </a:xfrm>
           <a:prstGeom prst="rect">
@@ -2506,7 +2506,7 @@
                 <a:ea typeface="Arial" pitchFamily="34" charset="-122"/>
                 <a:cs typeface="Arial" pitchFamily="34" charset="-120"/>
               </a:rPr>
-              <a:t>Quarterly · scorecard (first: end Sep)</a:t>
+              <a:t>Quarterly: scorecard (first at end of Sep)</a:t>
             </a:r>
             <a:endParaRPr lang="en-US" sz="850" dirty="0"/>
           </a:p>
@@ -2526,7 +2526,7 @@
                 <a:ea typeface="Arial" pitchFamily="34" charset="-122"/>
                 <a:cs typeface="Arial" pitchFamily="34" charset="-120"/>
               </a:rPr>
-              <a:t>Revolut-style review per PM: Culture · Skills · Deliverables = (Speed + Quality) × Complexity, vs seniority talent bar → A-player / Above bar / Underperformer. A-players 15–25%, calibrated.</a:t>
+              <a:t>Revolut-style review per PM: Culture, Skills, and Deliverables = (Speed + Quality) x Complexity, against the seniority talent bar. Grades: A-player, Above bar, Underperformer. A-players calibrated to 15-25%.</a:t>
             </a:r>
             <a:endParaRPr lang="en-US" sz="850" dirty="0"/>
           </a:p>
@@ -2540,7 +2540,7 @@
         </p:nvSpPr>
         <p:spPr>
           <a:xfrm>
-            <a:off x="8613648" y="3268980"/>
+            <a:off x="8613648" y="3552444"/>
             <a:ext cx="3163824" cy="475488"/>
           </a:xfrm>
           <a:prstGeom prst="rect">
@@ -2568,7 +2568,7 @@
                 <a:ea typeface="Arial" pitchFamily="34" charset="-122"/>
                 <a:cs typeface="Arial" pitchFamily="34" charset="-120"/>
               </a:rPr>
-              <a:t>Semi-annual · promotion &amp; pay</a:t>
+              <a:t>Semi-annual: promotion and pay</a:t>
             </a:r>
             <a:endParaRPr lang="en-US" sz="850" dirty="0"/>
           </a:p>
@@ -2588,7 +2588,7 @@
                 <a:ea typeface="Arial" pitchFamily="34" charset="-122"/>
                 <a:cs typeface="Arial" pitchFamily="34" charset="-120"/>
               </a:rPr>
-              <a:t>Promotions on sustained A-player grades; pay to benchmark; bonus multiplier = grade × KPI attainment.</a:t>
+              <a:t>Promotions on sustained A-player grades, pay to benchmark, bonus multiplier = grade x KPI attainment.</a:t>
             </a:r>
             <a:endParaRPr lang="en-US" sz="850" dirty="0"/>
           </a:p>
@@ -2602,7 +2602,7 @@
         </p:nvSpPr>
         <p:spPr>
           <a:xfrm>
-            <a:off x="8613648" y="3904488"/>
+            <a:off x="8613648" y="4187952"/>
             <a:ext cx="3163824" cy="1975104"/>
           </a:xfrm>
           <a:prstGeom prst="roundRect">
@@ -2637,7 +2637,7 @@
                 <a:ea typeface="Arial" pitchFamily="34" charset="-122"/>
                 <a:cs typeface="Arial" pitchFamily="34" charset="-120"/>
               </a:rPr>
-              <a:t>5 · TO AGREE TODAY</a:t>
+              <a:t>5. TO AGREE TODAY</a:t>
             </a:r>
             <a:endParaRPr lang="en-US" sz="880" dirty="0"/>
           </a:p>
@@ -2660,7 +2660,7 @@
                 <a:ea typeface="Arial" pitchFamily="34" charset="-122"/>
                 <a:cs typeface="Arial" pitchFamily="34" charset="-120"/>
               </a:rPr>
-              <a:t>1.  Tier 0 = PBT per line; phase per line as shown</a:t>
+              <a:t>1.  Tier 0 = PBT per line, phase per line as shown</a:t>
             </a:r>
             <a:endParaRPr lang="en-US" sz="880" dirty="0"/>
           </a:p>
@@ -2683,7 +2683,7 @@
                 <a:ea typeface="Arial" pitchFamily="34" charset="-122"/>
                 <a:cs typeface="Arial" pitchFamily="34" charset="-120"/>
               </a:rPr>
-              <a:t>2.  Volume targets: QRPh 107 · Moto 15 · Deals ramp timing · CL utilization target on 15 Aug</a:t>
+              <a:t>2.  Set the placeholder targets bottom-up: QRPh and Moto run rates, Deals ramp sizes and timing, CL utilization date</a:t>
             </a:r>
             <a:endParaRPr lang="en-US" sz="880" dirty="0"/>
           </a:p>
@@ -2706,7 +2706,7 @@
                 <a:ea typeface="Arial" pitchFamily="34" charset="-122"/>
                 <a:cs typeface="Arial" pitchFamily="34" charset="-120"/>
               </a:rPr>
-              <a:t>3.  Adopt the PO scorecard + talent bar for the 5 PMs; first review end of Sep</a:t>
+              <a:t>3.  Adopt the PO scorecard and talent bar for the 5 PMs, first review end of Sep</a:t>
             </a:r>
             <a:endParaRPr lang="en-US" sz="880" dirty="0"/>
           </a:p>
@@ -2729,7 +2729,7 @@
                 <a:ea typeface="Arial" pitchFamily="34" charset="-122"/>
                 <a:cs typeface="Arial" pitchFamily="34" charset="-120"/>
               </a:rPr>
-              <a:t>4.  Bonus linkage: scorecard grade × KPI attainment, team and lead</a:t>
+              <a:t>4.  Bonus linkage: scorecard grade x KPI attainment, team and lead</a:t>
             </a:r>
             <a:endParaRPr lang="en-US" sz="880" dirty="0"/>
           </a:p>
@@ -2768,7 +2768,7 @@
                 <a:ea typeface="Arial" pitchFamily="34" charset="-122"/>
                 <a:cs typeface="Arial" pitchFamily="34" charset="-120"/>
               </a:rPr>
-              <a:t>Working docs: Executive Project Tracker v2 (weekly, linked to the KPI tree, ClickUp links per row)  ·  KPI Targets H2 tab (monthly)  ·  QuantumLight Product Owner scorecard (quarterly).</a:t>
+              <a:t>Working docs: Executive Project Tracker v2 (weekly, shared, linked to the KPI tree and ClickUp), KPI Targets H2 tab (monthly), QuantumLight Product Owner scorecard (quarterly), Delivery Scoreboard (Kurt only).</a:t>
             </a:r>
             <a:endParaRPr lang="en-US" sz="800" dirty="0"/>
           </a:p>

</xml_diff>